<commit_message>
Fix slide 7 (What Each Stage Catches) to cover all 7 Spec Kit stages
Previously only listed 4 of the 7 stages (specify, clarify, plan,
analyze), with no framing sentence explaining what "catches" even
means -- confusing on its own. Now covers all seven (constitution,
specify, clarify, plan, tasks, analyze, implement), each mapped to the
specific class of mistake it exists to catch, with an intro line and a
speaker note. Also fixes a real spacing bug this introduced along the
way: a leftover `top += Inches(1.0)` inside the row loop (on top of
the new `top += row_h`) would have pushed the 7 rows to ~12 inches,
overflowing the 7.5-inch slide -- caught by rendering and inspecting
the slide before committing, not left for a live rehearsal to find.

Applied to both build_deck.py (Hebrew) and build_deck_en.py (English)
to keep them in sync.

Co-Authored-By: Claude Sonnet 5 <noreply@anthropic.com>
</commit_message>
<xml_diff>
--- a/presentation/speckit-workshop-draft-en.pptx
+++ b/presentation/speckit-workshop-draft-en.pptx
@@ -597,7 +597,11 @@
         <p:txBody>
           <a:bodyPr/>
           <a:lstStyle/>
-          <a:p/>
+          <a:p>
+            <a:r>
+              <a:t>Don't dive into command syntax -- the goal is the mental model.</a:t>
+            </a:r>
+          </a:p>
         </p:txBody>
       </p:sp>
       <p:sp>
@@ -663,11 +667,7 @@
         <p:txBody>
           <a:bodyPr/>
           <a:lstStyle/>
-          <a:p>
-            <a:r>
-              <a:t>'Spec Kit is not the coding agent. Claude Code or Codex do the work. The IDE is the human workspace.'</a:t>
-            </a:r>
-          </a:p>
+          <a:p/>
         </p:txBody>
       </p:sp>
       <p:sp>
@@ -735,7 +735,7 @@
           <a:lstStyle/>
           <a:p>
             <a:r>
-              <a:t>screenshots #6-7.</a:t>
+              <a:t>'Spec Kit is not the coding agent. Claude Code or Codex do the work. The IDE is the human workspace.'</a:t>
             </a:r>
           </a:p>
         </p:txBody>
@@ -803,7 +803,11 @@
         <p:txBody>
           <a:bodyPr/>
           <a:lstStyle/>
-          <a:p/>
+          <a:p>
+            <a:r>
+              <a:t>screenshots #6-7.</a:t>
+            </a:r>
+          </a:p>
         </p:txBody>
       </p:sp>
       <p:sp>
@@ -935,11 +939,7 @@
         <p:txBody>
           <a:bodyPr/>
           <a:lstStyle/>
-          <a:p>
-            <a:r>
-              <a:t>Not a framework survey -- that's not the point of this workshop.</a:t>
-            </a:r>
-          </a:p>
+          <a:p/>
         </p:txBody>
       </p:sp>
       <p:sp>
@@ -1005,7 +1005,11 @@
         <p:txBody>
           <a:bodyPr/>
           <a:lstStyle/>
-          <a:p/>
+          <a:p>
+            <a:r>
+              <a:t>Not a framework survey -- that's not the point of this workshop.</a:t>
+            </a:r>
+          </a:p>
         </p:txBody>
       </p:sp>
       <p:sp>
@@ -1071,11 +1075,7 @@
         <p:txBody>
           <a:bodyPr/>
           <a:lstStyle/>
-          <a:p>
-            <a:r>
-              <a:t>Visual: examples/prompt-only/naive_monitor.ino</a:t>
-            </a:r>
-          </a:p>
+          <a:p/>
         </p:txBody>
       </p:sp>
       <p:sp>
@@ -1141,7 +1141,11 @@
         <p:txBody>
           <a:bodyPr/>
           <a:lstStyle/>
-          <a:p/>
+          <a:p>
+            <a:r>
+              <a:t>Visual: examples/prompt-only/naive_monitor.ino</a:t>
+            </a:r>
+          </a:p>
         </p:txBody>
       </p:sp>
       <p:sp>
@@ -1207,11 +1211,7 @@
         <p:txBody>
           <a:bodyPr/>
           <a:lstStyle/>
-          <a:p>
-            <a:r>
-              <a:t>This is not a programming problem. It's a product decision that had to be made *before* writing code.</a:t>
-            </a:r>
-          </a:p>
+          <a:p/>
         </p:txBody>
       </p:sp>
       <p:sp>
@@ -1349,7 +1349,7 @@
           <a:lstStyle/>
           <a:p>
             <a:r>
-              <a:t>screenshots #10-11 (plan.md, tasks.md) if you want to also show the files themselves.</a:t>
+              <a:t>This is not a programming problem. It's a product decision that had to be made *before* writing code.</a:t>
             </a:r>
           </a:p>
         </p:txBody>
@@ -1419,7 +1419,7 @@
           <a:lstStyle/>
           <a:p>
             <a:r>
-              <a:t>Most important slide -- don't rush through it. This is not a made-up example for the talk -- it really happened while building this project. Can show live: git show b91cd94 -- specs/001-heltec-monitor/spec.md</a:t>
+              <a:t>screenshots #10-11 (plan.md, tasks.md) if you want to also show the files themselves.</a:t>
             </a:r>
           </a:p>
         </p:txBody>
@@ -1489,7 +1489,7 @@
           <a:lstStyle/>
           <a:p>
             <a:r>
-              <a:t>The strongest demonstration of Spec Kit's value in the entire talk.</a:t>
+              <a:t>Most important slide -- don't rush through it. This is not a made-up example for the talk -- it really happened while building this project. Can show live: git show b91cd94 -- specs/001-heltec-monitor/spec.md</a:t>
             </a:r>
           </a:p>
         </p:txBody>
@@ -1557,7 +1557,11 @@
         <p:txBody>
           <a:bodyPr/>
           <a:lstStyle/>
-          <a:p/>
+          <a:p>
+            <a:r>
+              <a:t>The strongest demonstration of Spec Kit's value in the entire talk.</a:t>
+            </a:r>
+          </a:p>
         </p:txBody>
       </p:sp>
       <p:sp>
@@ -1623,11 +1627,7 @@
         <p:txBody>
           <a:bodyPr/>
           <a:lstStyle/>
-          <a:p>
-            <a:r>
-              <a:t>Everything on this slide depends on the physical hardware test, which hasn't happened yet.</a:t>
-            </a:r>
-          </a:p>
+          <a:p/>
         </p:txBody>
       </p:sp>
       <p:sp>
@@ -1695,7 +1695,7 @@
           <a:lstStyle/>
           <a:p>
             <a:r>
-              <a:t>Every stage already exists as a tag in the repository -- the demo doesn't depend on a live AI run that could fail on stage.</a:t>
+              <a:t>Everything on this slide depends on the physical hardware test, which hasn't happened yet.</a:t>
             </a:r>
           </a:p>
         </p:txBody>
@@ -1763,7 +1763,11 @@
         <p:txBody>
           <a:bodyPr/>
           <a:lstStyle/>
-          <a:p/>
+          <a:p>
+            <a:r>
+              <a:t>Every stage already exists as a tag in the repository -- the demo doesn't depend on a live AI run that could fail on stage.</a:t>
+            </a:r>
+          </a:p>
         </p:txBody>
       </p:sp>
       <p:sp>
@@ -1829,6 +1833,72 @@
         <p:txBody>
           <a:bodyPr/>
           <a:lstStyle/>
+          <a:p/>
+        </p:txBody>
+      </p:sp>
+      <p:sp>
+        <p:nvSpPr>
+          <p:cNvPr id="4" name="Slide Number Placeholder 3"/>
+          <p:cNvSpPr>
+            <a:spLocks noGrp="1"/>
+          </p:cNvSpPr>
+          <p:nvPr>
+            <p:ph type="sldNum" idx="5" sz="quarter"/>
+          </p:nvPr>
+        </p:nvSpPr>
+        <p:spPr/>
+      </p:sp>
+    </p:spTree>
+  </p:cSld>
+  <p:clrMapOvr>
+    <a:masterClrMapping/>
+  </p:clrMapOvr>
+</p:notes>
+</file>
+
+<file path=ppt/notesSlides/notesSlide28.xml><?xml version="1.0" encoding="utf-8"?>
+<p:notes xmlns:a="http://schemas.openxmlformats.org/drawingml/2006/main" xmlns:p="http://schemas.openxmlformats.org/presentationml/2006/main" xmlns:r="http://schemas.openxmlformats.org/officeDocument/2006/relationships">
+  <p:cSld>
+    <p:spTree>
+      <p:nvGrpSpPr>
+        <p:cNvPr id="1" name=""/>
+        <p:cNvGrpSpPr/>
+        <p:nvPr/>
+      </p:nvGrpSpPr>
+      <p:grpSpPr>
+        <a:xfrm>
+          <a:off x="0" y="0"/>
+          <a:ext cx="0" cy="0"/>
+          <a:chOff x="0" y="0"/>
+          <a:chExt cx="0" cy="0"/>
+        </a:xfrm>
+      </p:grpSpPr>
+      <p:sp>
+        <p:nvSpPr>
+          <p:cNvPr id="2" name="Slide Image Placeholder 1"/>
+          <p:cNvSpPr>
+            <a:spLocks noGrp="1"/>
+          </p:cNvSpPr>
+          <p:nvPr>
+            <p:ph type="sldImg" idx="2"/>
+          </p:nvPr>
+        </p:nvSpPr>
+        <p:spPr/>
+      </p:sp>
+      <p:sp>
+        <p:nvSpPr>
+          <p:cNvPr id="3" name="Notes Placeholder 2"/>
+          <p:cNvSpPr>
+            <a:spLocks noGrp="1"/>
+          </p:cNvSpPr>
+          <p:nvPr>
+            <p:ph type="body" idx="3" sz="quarter"/>
+          </p:nvPr>
+        </p:nvSpPr>
+        <p:spPr/>
+        <p:txBody>
+          <a:bodyPr/>
+          <a:lstStyle/>
           <a:p>
             <a:r>
               <a:t>See presentation/slide-links.md for the full list.</a:t>
@@ -2181,7 +2251,7 @@
           <a:lstStyle/>
           <a:p>
             <a:r>
-              <a:t>screenshots #1-2 from the checklist.</a:t>
+              <a:t>Walk through all seven stages briefly here; the deep dive on each one comes later in the Heltec walkthrough section.</a:t>
             </a:r>
           </a:p>
         </p:txBody>
@@ -2251,7 +2321,7 @@
           <a:lstStyle/>
           <a:p>
             <a:r>
-              <a:t>This is the real output from this repo's own initialization.</a:t>
+              <a:t>screenshots #1-2 from the checklist.</a:t>
             </a:r>
           </a:p>
         </p:txBody>
@@ -2321,7 +2391,7 @@
           <a:lstStyle/>
           <a:p>
             <a:r>
-              <a:t>Don't dive into command syntax -- the goal is the mental model.</a:t>
+              <a:t>This is the real output from this repo's own initialization.</a:t>
             </a:r>
           </a:p>
         </p:txBody>
@@ -8690,8 +8760,8 @@
         </p:nvSpPr>
         <p:spPr>
           <a:xfrm>
-            <a:off x="731520" y="1463040"/>
-            <a:ext cx="10728655" cy="731520"/>
+            <a:off x="731520" y="960120"/>
+            <a:ext cx="10728655" cy="457200"/>
           </a:xfrm>
           <a:prstGeom prst="rect">
             <a:avLst/>
@@ -8699,29 +8769,20 @@
           <a:noFill/>
         </p:spPr>
         <p:txBody>
-          <a:bodyPr wrap="none">
+          <a:bodyPr wrap="square">
             <a:spAutoFit/>
           </a:bodyPr>
           <a:lstStyle/>
           <a:p>
             <a:pPr algn="l"/>
             <a:r>
-              <a:rPr sz="2400" b="1">
-                <a:solidFill>
-                  <a:srgbClr val="2563EB"/>
-                </a:solidFill>
-                <a:latin typeface="Courier New"/>
-              </a:rPr>
-              <a:t>Specification</a:t>
-            </a:r>
-            <a:r>
-              <a:rPr sz="2400">
+              <a:rPr sz="1800" i="1">
                 <a:solidFill>
                   <a:srgbClr val="334155"/>
                 </a:solidFill>
                 <a:latin typeface="Arial"/>
               </a:rPr>
-              <a:t>    →    We never agreed what this does</a:t>
+              <a:t>Every stage exists to catch one specific kind of mistake -- before it becomes code:</a:t>
             </a:r>
           </a:p>
         </p:txBody>
@@ -8734,8 +8795,8 @@
         </p:nvSpPr>
         <p:spPr>
           <a:xfrm>
-            <a:off x="731520" y="2377440"/>
-            <a:ext cx="10728655" cy="731520"/>
+            <a:off x="731520" y="1600200"/>
+            <a:ext cx="10728655" cy="621792"/>
           </a:xfrm>
           <a:prstGeom prst="rect">
             <a:avLst/>
@@ -8750,22 +8811,22 @@
           <a:p>
             <a:pPr algn="l"/>
             <a:r>
-              <a:rPr sz="2400" b="1">
+              <a:rPr sz="2100" b="1">
                 <a:solidFill>
                   <a:srgbClr val="2563EB"/>
                 </a:solidFill>
                 <a:latin typeface="Courier New"/>
               </a:rPr>
-              <a:t>Clarify</a:t>
-            </a:r>
-            <a:r>
-              <a:rPr sz="2400">
+              <a:t>constitution </a:t>
+            </a:r>
+            <a:r>
+              <a:rPr sz="2000" i="0">
                 <a:solidFill>
                   <a:srgbClr val="334155"/>
                 </a:solidFill>
                 <a:latin typeface="Arial"/>
               </a:rPr>
-              <a:t>    →    We agreed on the happy path, not the edges</a:t>
+              <a:t>  →  A rule gets silently broken because nobody wrote it down</a:t>
             </a:r>
           </a:p>
         </p:txBody>
@@ -8778,8 +8839,8 @@
         </p:nvSpPr>
         <p:spPr>
           <a:xfrm>
-            <a:off x="731520" y="3291840"/>
-            <a:ext cx="10728655" cy="731520"/>
+            <a:off x="731520" y="2221992"/>
+            <a:ext cx="10728655" cy="621792"/>
           </a:xfrm>
           <a:prstGeom prst="rect">
             <a:avLst/>
@@ -8794,22 +8855,22 @@
           <a:p>
             <a:pPr algn="l"/>
             <a:r>
-              <a:rPr sz="2400" b="1">
+              <a:rPr sz="2100" b="1">
                 <a:solidFill>
                   <a:srgbClr val="2563EB"/>
                 </a:solidFill>
                 <a:latin typeface="Courier New"/>
               </a:rPr>
-              <a:t>Plan</a:t>
-            </a:r>
-            <a:r>
-              <a:rPr sz="2400">
+              <a:t>specify      </a:t>
+            </a:r>
+            <a:r>
+              <a:rPr sz="2000" i="0">
                 <a:solidFill>
                   <a:srgbClr val="334155"/>
                 </a:solidFill>
                 <a:latin typeface="Arial"/>
               </a:rPr>
-              <a:t>    →    We agreed on what, not how</a:t>
+              <a:t>  →  We never agreed what this does</a:t>
             </a:r>
           </a:p>
         </p:txBody>
@@ -8822,8 +8883,8 @@
         </p:nvSpPr>
         <p:spPr>
           <a:xfrm>
-            <a:off x="731520" y="4206240"/>
-            <a:ext cx="10728655" cy="731520"/>
+            <a:off x="731520" y="2843784"/>
+            <a:ext cx="10728655" cy="621792"/>
           </a:xfrm>
           <a:prstGeom prst="rect">
             <a:avLst/>
@@ -8838,22 +8899,198 @@
           <a:p>
             <a:pPr algn="l"/>
             <a:r>
-              <a:rPr sz="2400" b="1">
+              <a:rPr sz="2100" b="1">
                 <a:solidFill>
                   <a:srgbClr val="2563EB"/>
                 </a:solidFill>
                 <a:latin typeface="Courier New"/>
               </a:rPr>
-              <a:t>Analyze</a:t>
-            </a:r>
-            <a:r>
-              <a:rPr sz="2400">
+              <a:t>clarify      </a:t>
+            </a:r>
+            <a:r>
+              <a:rPr sz="2000" i="0">
                 <a:solidFill>
                   <a:srgbClr val="334155"/>
                 </a:solidFill>
                 <a:latin typeface="Arial"/>
               </a:rPr>
-              <a:t>    →    Two of our own documents contradict each other</a:t>
+              <a:t>  →  We agreed on the happy path, not the edges</a:t>
+            </a:r>
+          </a:p>
+        </p:txBody>
+      </p:sp>
+      <p:sp>
+        <p:nvSpPr>
+          <p:cNvPr id="7" name="TextBox 6"/>
+          <p:cNvSpPr txBox="1"/>
+          <p:nvPr/>
+        </p:nvSpPr>
+        <p:spPr>
+          <a:xfrm>
+            <a:off x="731520" y="3465576"/>
+            <a:ext cx="10728655" cy="621792"/>
+          </a:xfrm>
+          <a:prstGeom prst="rect">
+            <a:avLst/>
+          </a:prstGeom>
+          <a:noFill/>
+        </p:spPr>
+        <p:txBody>
+          <a:bodyPr wrap="none">
+            <a:spAutoFit/>
+          </a:bodyPr>
+          <a:lstStyle/>
+          <a:p>
+            <a:pPr algn="l"/>
+            <a:r>
+              <a:rPr sz="2100" b="1">
+                <a:solidFill>
+                  <a:srgbClr val="2563EB"/>
+                </a:solidFill>
+                <a:latin typeface="Courier New"/>
+              </a:rPr>
+              <a:t>plan         </a:t>
+            </a:r>
+            <a:r>
+              <a:rPr sz="2000" i="0">
+                <a:solidFill>
+                  <a:srgbClr val="334155"/>
+                </a:solidFill>
+                <a:latin typeface="Arial"/>
+              </a:rPr>
+              <a:t>  →  We agreed on what, not how -- and how has real constraints</a:t>
+            </a:r>
+          </a:p>
+        </p:txBody>
+      </p:sp>
+      <p:sp>
+        <p:nvSpPr>
+          <p:cNvPr id="8" name="TextBox 7"/>
+          <p:cNvSpPr txBox="1"/>
+          <p:nvPr/>
+        </p:nvSpPr>
+        <p:spPr>
+          <a:xfrm>
+            <a:off x="731520" y="4087368"/>
+            <a:ext cx="10728655" cy="621792"/>
+          </a:xfrm>
+          <a:prstGeom prst="rect">
+            <a:avLst/>
+          </a:prstGeom>
+          <a:noFill/>
+        </p:spPr>
+        <p:txBody>
+          <a:bodyPr wrap="none">
+            <a:spAutoFit/>
+          </a:bodyPr>
+          <a:lstStyle/>
+          <a:p>
+            <a:pPr algn="l"/>
+            <a:r>
+              <a:rPr sz="2100" b="1">
+                <a:solidFill>
+                  <a:srgbClr val="2563EB"/>
+                </a:solidFill>
+                <a:latin typeface="Courier New"/>
+              </a:rPr>
+              <a:t>tasks        </a:t>
+            </a:r>
+            <a:r>
+              <a:rPr sz="2000" i="0">
+                <a:solidFill>
+                  <a:srgbClr val="334155"/>
+                </a:solidFill>
+                <a:latin typeface="Arial"/>
+              </a:rPr>
+              <a:t>  →  We know the plan, not the order or the dependencies</a:t>
+            </a:r>
+          </a:p>
+        </p:txBody>
+      </p:sp>
+      <p:sp>
+        <p:nvSpPr>
+          <p:cNvPr id="9" name="TextBox 8"/>
+          <p:cNvSpPr txBox="1"/>
+          <p:nvPr/>
+        </p:nvSpPr>
+        <p:spPr>
+          <a:xfrm>
+            <a:off x="731520" y="4709160"/>
+            <a:ext cx="10728655" cy="621792"/>
+          </a:xfrm>
+          <a:prstGeom prst="rect">
+            <a:avLst/>
+          </a:prstGeom>
+          <a:noFill/>
+        </p:spPr>
+        <p:txBody>
+          <a:bodyPr wrap="none">
+            <a:spAutoFit/>
+          </a:bodyPr>
+          <a:lstStyle/>
+          <a:p>
+            <a:pPr algn="l"/>
+            <a:r>
+              <a:rPr sz="2100" b="1">
+                <a:solidFill>
+                  <a:srgbClr val="2563EB"/>
+                </a:solidFill>
+                <a:latin typeface="Courier New"/>
+              </a:rPr>
+              <a:t>analyze      </a:t>
+            </a:r>
+            <a:r>
+              <a:rPr sz="2000" i="0">
+                <a:solidFill>
+                  <a:srgbClr val="334155"/>
+                </a:solidFill>
+                <a:latin typeface="Arial"/>
+              </a:rPr>
+              <a:t>  →  Two of our own documents quietly contradict each other</a:t>
+            </a:r>
+          </a:p>
+        </p:txBody>
+      </p:sp>
+      <p:sp>
+        <p:nvSpPr>
+          <p:cNvPr id="10" name="TextBox 9"/>
+          <p:cNvSpPr txBox="1"/>
+          <p:nvPr/>
+        </p:nvSpPr>
+        <p:spPr>
+          <a:xfrm>
+            <a:off x="731520" y="5330952"/>
+            <a:ext cx="10728655" cy="621792"/>
+          </a:xfrm>
+          <a:prstGeom prst="rect">
+            <a:avLst/>
+          </a:prstGeom>
+          <a:noFill/>
+        </p:spPr>
+        <p:txBody>
+          <a:bodyPr wrap="none">
+            <a:spAutoFit/>
+          </a:bodyPr>
+          <a:lstStyle/>
+          <a:p>
+            <a:pPr algn="l"/>
+            <a:r>
+              <a:rPr sz="2100" b="1">
+                <a:solidFill>
+                  <a:srgbClr val="2563EB"/>
+                </a:solidFill>
+                <a:latin typeface="Courier New"/>
+              </a:rPr>
+              <a:t>implement    </a:t>
+            </a:r>
+            <a:r>
+              <a:rPr sz="2000" i="1">
+                <a:solidFill>
+                  <a:srgbClr val="334155"/>
+                </a:solidFill>
+                <a:latin typeface="Arial"/>
+              </a:rPr>
+              <a:t>  →  (this is the only step prompt-only starts from)</a:t>
             </a:r>
           </a:p>
         </p:txBody>

</xml_diff>

<commit_message>
Deepen English deck content: explain what/why GitHub Spec Kit is, expand notes
- New standalone "What Is GitHub Spec Kit -- and Why Does It Exist?" slide
  explaining it's GitHub's open-source toolkit, what it concretely is
  (CLI + agent skills), and the spec-driven-development motivation, for a
  fully novice audience.
- Expanded terse bullet fragments across ~20 slides into full, self-contained
  sentences so the deck reads clearly on its own, not just as talking points.
- Substantially expanded instructor speaker notes on every slide with
  concrete talking points, what to emphasize, and why each slide matters.
</commit_message>
<xml_diff>
--- a/presentation/speckit-workshop-draft-en.pptx
+++ b/presentation/speckit-workshop-draft-en.pptx
@@ -529,7 +529,7 @@
           <a:lstStyle/>
           <a:p>
             <a:r>
-              <a:t>Open with a question to the audience: who has ever asked an AI to write code straight from a prompt?</a:t>
+              <a:t>Open with a show of hands: who has ever asked an AI coding assistant to 'just build X' from a single sentence? Almost everyone has. This talk is about what happens next -- and about a specific, real embedded-systems example (a temperature monitor on a Heltec ESP32 board) that we'll follow from a vague prompt all the way to tested, working, physically-verified firmware. No prior Spec Kit, embedded, or even AI-agent experience is assumed.</a:t>
             </a:r>
           </a:p>
         </p:txBody>
@@ -599,7 +599,7 @@
           <a:lstStyle/>
           <a:p>
             <a:r>
-              <a:t>Don't dive into command syntax -- the goal is the mental model.</a:t>
+              <a:t>Don't dive into command syntax yet -- the goal here is just the mental model of the pipeline: constitution (project-wide rules, written once) -&gt; specify (what are we building) -&gt; clarify (resolve the ambiguous parts) -&gt; plan (technical approach) -&gt; tasks (break the plan into ordered, checkable steps) -&gt; analyze (automatically cross-check spec/plan/tasks for contradictions) -&gt; implement (the agent writes the code). Each stage produces a real file in the repo, which is the subject of the next slide. We already previewed *why* each stage exists on slide 7 -- this slide is the order they run in.</a:t>
             </a:r>
           </a:p>
         </p:txBody>
@@ -667,7 +667,11 @@
         <p:txBody>
           <a:bodyPr/>
           <a:lstStyle/>
-          <a:p/>
+          <a:p>
+            <a:r>
+              <a:t>This is a good moment to actually open specs/001-heltec-monitor/spec.md in the editor if you have it up, even just to scroll through it -- seeing a real, readable Markdown file (not code, not JSON) tends to de-mystify the whole idea for a novice audience.</a:t>
+            </a:r>
+          </a:p>
         </p:txBody>
       </p:sp>
       <p:sp>
@@ -735,7 +739,7 @@
           <a:lstStyle/>
           <a:p>
             <a:r>
-              <a:t>'Spec Kit is not the coding agent. Claude Code or Codex do the work. The IDE is the human workspace.'</a:t>
+              <a:t>Say this explicitly, it's the most common point of confusion for newcomers: Spec Kit is not a coding agent and does not write code. Claude Code or Codex are the agents that actually read the spec/plan/tasks files and write the firmware. The IDE (VS Code, CLion/JetBrains) is just the human's workspace for reading and editing files alongside the agent. So the stack is: IDE (human) + coding agent (does the work) + Spec Kit (the structured process the agent follows) -- three separate, replaceable layers, not one product.</a:t>
             </a:r>
           </a:p>
         </p:txBody>
@@ -805,7 +809,7 @@
           <a:lstStyle/>
           <a:p>
             <a:r>
-              <a:t>screenshots #6-7.</a:t>
+              <a:t>Live screenshots #6-7 on the checklist would go here. If you have a live terminal available, it's worth actually running /speckit-specify in one agent and $speckit-specify in the other against this repo to show it's the same underlying skill, just a different trigger syntax per agent.</a:t>
             </a:r>
           </a:p>
         </p:txBody>
@@ -873,7 +877,11 @@
         <p:txBody>
           <a:bodyPr/>
           <a:lstStyle/>
-          <a:p/>
+          <a:p>
+            <a:r>
+              <a:t>Keep this brief -- the point is that the editor is the least important choice in this whole workflow. Don't get pulled into an extensions debate; two extensions is the whole list.</a:t>
+            </a:r>
+          </a:p>
         </p:txBody>
       </p:sp>
       <p:sp>
@@ -939,7 +947,11 @@
         <p:txBody>
           <a:bodyPr/>
           <a:lstStyle/>
-          <a:p/>
+          <a:p>
+            <a:r>
+              <a:t>Traceability here means: can you point to the exact moment and reason a requirement was decided? Repeatability means: if you handed this same spec to a different agent, or ran the process again, would you land on roughly the same result? Both are naturally low with a single ad-hoc prompt because nothing was written down -- and naturally higher with Spec Kit because the requirements are files, not memory.</a:t>
+            </a:r>
+          </a:p>
         </p:txBody>
       </p:sp>
       <p:sp>
@@ -1007,7 +1019,7 @@
           <a:lstStyle/>
           <a:p>
             <a:r>
-              <a:t>Not a framework survey -- that's not the point of this workshop.</a:t>
+              <a:t>Not a framework survey -- don't spend more than a minute here, this isn't the point of the workshop. The only message worth landing: this is a spectrum (no process -&gt; Spec Kit -&gt; heavier multi-agent frameworks), and the right amount of process depends on project size and team size.</a:t>
             </a:r>
           </a:p>
         </p:txBody>
@@ -1075,7 +1087,11 @@
         <p:txBody>
           <a:bodyPr/>
           <a:lstStyle/>
-          <a:p/>
+          <a:p>
+            <a:r>
+              <a:t>This slide exists to establish real hardware credibility before we compare the two build approaches -- everything from here on is grounded in an actual physical board, not a toy example.</a:t>
+            </a:r>
+          </a:p>
         </p:txBody>
       </p:sp>
       <p:sp>
@@ -1143,7 +1159,7 @@
           <a:lstStyle/>
           <a:p>
             <a:r>
-              <a:t>Visual: examples/prompt-only/naive_monitor.ino</a:t>
+              <a:t>Visual: examples/prompt-only/naive_monitor.ino. If you have it open, scroll to the threshold check and point out there is exactly one comparison (value &gt; 30) with no second condition for clearing the warning -- that single missing 'else' branch is the whole hysteresis story, and it's coming up in detail on slide 20.</a:t>
             </a:r>
           </a:p>
         </p:txBody>
@@ -1211,7 +1227,11 @@
         <p:txBody>
           <a:bodyPr/>
           <a:lstStyle/>
-          <a:p/>
+          <a:p>
+            <a:r>
+              <a:t>This is the real clarify transcript from this project, not a mockup. Point out that these are exactly the kind of questions a careful human reviewer would ask -- the agent is just asking them earlier, before writing any code, and recording the answers so they're never lost.</a:t>
+            </a:r>
+          </a:p>
         </p:txBody>
       </p:sp>
       <p:sp>
@@ -1279,7 +1299,7 @@
           <a:lstStyle/>
           <a:p>
             <a:r>
-              <a:t>Open question to the audience -- give them a moment to think before continuing.</a:t>
+              <a:t>Read the prompt out loud, slowly. It sounds complete -- it has a sensor, a display, a warning. That's the trap: it reads like a spec but it isn't one. Give the audience a real moment of silence here before moving to slide 3, where we'll pull apart everything this single sentence quietly left undecided.</a:t>
             </a:r>
           </a:p>
         </p:txBody>
@@ -1349,7 +1369,7 @@
           <a:lstStyle/>
           <a:p>
             <a:r>
-              <a:t>This is not a programming problem. It's a product decision that had to be made *before* writing code.</a:t>
+              <a:t>Walk through the diagram left to right: temperature crosses 30°C, WARNING turns on. Without a tolerance band, the moment temperature drops back to 29.9°C the display would flip straight back to OK, then back to WARNING at the next tiny fluctuation -- flickering on every crossing of a single number. The band (here, 28-30°C) means once WARNING is on, it *stays* on anywhere inside the band, and only clears once the temperature drops below the lower edge (28°C). This is not a programming problem to be debugged -- it is a product decision (how much tolerance is acceptable) that had to be made before a single line of the state machine was written, which is exactly the kind of decision the clarify stage exists to surface.</a:t>
             </a:r>
           </a:p>
         </p:txBody>
@@ -1419,7 +1439,7 @@
           <a:lstStyle/>
           <a:p>
             <a:r>
-              <a:t>screenshots #10-11 (plan.md, tasks.md) if you want to also show the files themselves.</a:t>
+              <a:t>plan turns the now-clarified requirements into a concrete technical approach: which board, which libraries, and critically, an architecture split into three separable pieces -- a sensor adapter, pure decision logic with zero hardware dependencies, and an OLED/Serial reporter. tasks then breaks that plan into small, ordered, checkable steps an agent (or a human) can execute one at a time. The architecture split shown here is what makes the next slide's automated testing possible: because the decision logic touches no hardware, it can be tested on a laptop with no Heltec board plugged in at all. If you want to also show the raw files, screenshots #10-11 on the checklist are plan.md and tasks.md themselves.</a:t>
             </a:r>
           </a:p>
         </p:txBody>
@@ -1489,7 +1509,7 @@
           <a:lstStyle/>
           <a:p>
             <a:r>
-              <a:t>Most important slide -- don't rush through it. This is not a made-up example for the talk -- it really happened while building this project. Can show live: git show b91cd94 -- specs/001-heltec-monitor/spec.md</a:t>
+              <a:t>The most important slide in the whole talk -- do not rush through it. Walk through each of the five boxes: (1) during clarify, we decided the warning should stay on inside the hysteresis band; (2) but a separate success criterion (SC-004), written earlier, still described the old, simpler on/off behavior -- nobody noticed the two now disagreed; (3) /speckit-analyze, which cross-checks spec/plan/tasks against each other automatically, caught that contradiction; (4) the spec was corrected on the spot; (5) implementation only began after the documents agreed with each other. This is not a made-up example built for this talk -- it genuinely happened while building this exact project, and the full record is preserved in specs/001-heltec-monitor/analysis-report.md. If you have a terminal, show it live: git show b91cd94 -- specs/001-heltec-monitor/spec.md reproduces the exact diff.</a:t>
             </a:r>
           </a:p>
         </p:txBody>
@@ -1559,7 +1579,7 @@
           <a:lstStyle/>
           <a:p>
             <a:r>
-              <a:t>The strongest demonstration of Spec Kit's value in the entire talk.</a:t>
+              <a:t>The strongest demonstration of Spec Kit's value in the entire talk -- if the audience remembers one concrete moment from this workshop, it should be this one. The image below is the real diff: the old wording of SC-004 on the left/red, the corrected wording on the right/green, showing the success criterion updated to match the hysteresis decision from clarify. Emphasize: no code had been written yet when this was caught -- fixing a contradiction between two Markdown documents costs a few seconds; fixing the same contradiction after it had already become two conflicting pieces of firmware behavior would have cost far more, and might not have been caught at all without a hardware test that exercises that exact edge case.</a:t>
             </a:r>
           </a:p>
         </p:txBody>
@@ -1627,7 +1647,11 @@
         <p:txBody>
           <a:bodyPr/>
           <a:lstStyle/>
-          <a:p/>
+          <a:p>
+            <a:r>
+              <a:t>implement is the stage that finally writes the actual firmware code, following plan.md and tasks.md in order. Because the decision logic (monitor_logic, shown above) was designed with zero hardware dependencies back in the plan stage, it can be exercised by an automated test suite running natively on a laptop -- no Heltec board, no serial cable, nothing physical required. The panel on the bottom-left is the real, unedited output of that test run: 11 out of 11 tests passing. This is why we can already have high confidence in the decision logic itself before ever touching real hardware -- what's still unverified is only the physical wiring, sensor, and display, which is exactly what the next two slides are about.</a:t>
+            </a:r>
+          </a:p>
         </p:txBody>
       </p:sp>
       <p:sp>
@@ -1971,7 +1995,7 @@
           <a:lstStyle/>
           <a:p>
             <a:r>
-              <a:t>Can briefly show examples/prompt-only/naive_monitor.ino here.</a:t>
+              <a:t>Each bullet is a real decision, and an unspecified prompt does not remove the decision -- it just moves it into the model's head, where you can't see it, review it, or agree with it. Optionally show examples/prompt-only/naive_monitor.ino here to prove these aren't hypothetical: point out which lines in the real generated code quietly picked an answer to each question above.</a:t>
             </a:r>
           </a:p>
         </p:txBody>
@@ -2041,7 +2065,7 @@
           <a:lstStyle/>
           <a:p>
             <a:r>
-              <a:t>This is the one sentence the audience should remember from the whole workshop. Pause here for a beat.</a:t>
+              <a:t>This is the one sentence the audience should remember from the whole workshop -- pause for a beat after reading it aloud. Modern AI models are already good enough at writing code; that is not the bottleneck anymore. The bottleneck moved upstream, to deciding *what* the code should do. Spec Kit, which we introduce shortly, is a tool for making that decision-making step explicit and structured instead of implicit and skipped.</a:t>
             </a:r>
           </a:p>
         </p:txBody>
@@ -2111,7 +2135,7 @@
           <a:lstStyle/>
           <a:p>
             <a:r>
-              <a:t>Focus on the top half of the diagram for now. Every 'Fix' is a product decision made after code already exists that contradicts it.</a:t>
+              <a:t>Focus only on the TOP half of this diagram for now (we'll come back to the bottom half on the next slide). This is the ordinary loop when you skip specification: prompt -&gt; code -&gt; you notice something is wrong -&gt; you send a follow-up prompt to fix it -&gt; that fix reveals or breaks something else -&gt; repeat. Every 'Fix' box is a product decision that got made *after* code already existed and contradicted it -- which is the most expensive possible time to make that decision, because now there's already code and possibly a user depending on the wrong behavior.</a:t>
             </a:r>
           </a:p>
         </p:txBody>
@@ -2181,7 +2205,7 @@
           <a:lstStyle/>
           <a:p>
             <a:r>
-              <a:t>Now focus on the bottom half. The difference isn't 'more bureaucracy' -- it's moving decisions to where they're cheap to make.</a:t>
+              <a:t>Now point at the BOTTOM half of the same diagram. The difference is not 'more paperwork' -- it's the same decisions (which sensor, what threshold, what happens on error) being made once, on purpose, in a short clarification step, before any code exists -- instead of one at a time, by accident, after code already exists and needs to be un-written. Same total number of decisions either way; the only thing that changes is *when* they get made, and that timing is the entire value proposition of this workshop.</a:t>
             </a:r>
           </a:p>
         </p:txBody>
@@ -2321,7 +2345,7 @@
           <a:lstStyle/>
           <a:p>
             <a:r>
-              <a:t>screenshots #1-2 from the checklist.</a:t>
+              <a:t>This slide is the anchor for the whole talk -- take your time. Key points to say out loud: (1) it's from GitHub, it's free and open-source, this is not a pitch for a paid product; (2) it doesn't replace Claude Code or Codex -- those are the agents that actually write code, Spec Kit is the structured process layer on top of them (this gets its own diagram two slides from now); (3) the motivating problem is exactly what slides 2-4 just showed: fast code generation exposed how much of the real work is actually deciding what to build. If time allows, briefly show the real Spec Kit GitHub repo and its README (screenshots #1-2 on the checklist) so the audience sees this is a real, actively maintained project, not a one-off script.</a:t>
             </a:r>
           </a:p>
         </p:txBody>
@@ -2391,7 +2415,7 @@
           <a:lstStyle/>
           <a:p>
             <a:r>
-              <a:t>This is the real output from this repo's own initialization.</a:t>
+              <a:t>The first line installs the specify CLI itself (a one-time setup, via the uv Python tool). The second line runs it inside an existing project folder and tells it which agent to wire up -- here, Claude Code. This creates a .specify/ folder (templates, scripts, the project constitution) and a .claude/skills/ folder with the /speckit-... commands. The terminal output below is the real, unedited output captured from this repository's own initialization -- nothing here is staged or simulated.</a:t>
             </a:r>
           </a:p>
         </p:txBody>
@@ -5661,13 +5685,13 @@
               </a:spcAft>
             </a:pPr>
             <a:r>
-              <a:rPr sz="2200" b="0" i="0">
+              <a:rPr sz="2100" b="0" i="0">
                 <a:solidFill>
                   <a:srgbClr val="334155"/>
                 </a:solidFill>
                 <a:latin typeface="Arial"/>
               </a:rPr>
-              <a:t>Not a chat conversation that disappears</a:t>
+              <a:t>Every stage writes plain Markdown files into the repository -- they are committed to git like any other source file.</a:t>
             </a:r>
           </a:p>
           <a:p>
@@ -5677,13 +5701,29 @@
               </a:spcAft>
             </a:pPr>
             <a:r>
-              <a:rPr sz="2200" b="0" i="0">
+              <a:rPr sz="2100" b="0" i="0">
                 <a:solidFill>
                   <a:srgbClr val="334155"/>
                 </a:solidFill>
                 <a:latin typeface="Arial"/>
               </a:rPr>
-              <a:t>This is what lets you switch agents, come back a month later, and see exactly why each decision was made</a:t>
+              <a:t>That's the opposite of a chat conversation, which lives in one tool, is easy to lose, and is hard for a second person (or a second AI agent) to pick up later.</a:t>
+            </a:r>
+          </a:p>
+          <a:p>
+            <a:pPr algn="l">
+              <a:spcAft>
+                <a:spcPts val="1200"/>
+              </a:spcAft>
+            </a:pPr>
+            <a:r>
+              <a:rPr sz="2100" b="0" i="0">
+                <a:solidFill>
+                  <a:srgbClr val="334155"/>
+                </a:solidFill>
+                <a:latin typeface="Arial"/>
+              </a:rPr>
+              <a:t>Practical payoff: you can close the chat, switch from Claude Code to Codex, or come back to the project a month later, open spec.md, and see exactly what was decided and why -- without reconstructing it from memory.</a:t>
             </a:r>
           </a:p>
         </p:txBody>
@@ -5826,7 +5866,7 @@
         </p:nvSpPr>
         <p:spPr>
           <a:xfrm>
-            <a:off x="548640" y="1463040"/>
+            <a:off x="548640" y="1417320"/>
             <a:ext cx="11094415" cy="4206240"/>
           </a:xfrm>
           <a:prstGeom prst="rect">
@@ -5884,7 +5924,23 @@
                 </a:solidFill>
                 <a:latin typeface="Arial"/>
               </a:rPr>
-              <a:t>This isn't theoretical -- this repo has both integrations installed side by side</a:t>
+              <a:t>Same command, same underlying files, same result -- only the invocation syntax differs because each agent has its own convention for triggering a custom command.</a:t>
+            </a:r>
+          </a:p>
+          <a:p>
+            <a:pPr algn="l">
+              <a:spcAft>
+                <a:spcPts val="1200"/>
+              </a:spcAft>
+            </a:pPr>
+            <a:r>
+              <a:rPr sz="2000" b="0" i="0">
+                <a:solidFill>
+                  <a:srgbClr val="334155"/>
+                </a:solidFill>
+                <a:latin typeface="Arial"/>
+              </a:rPr>
+              <a:t>This isn't a theoretical claim -- this exact repository has both integrations installed side by side, and either agent can pick up the work where the other left off.</a:t>
             </a:r>
           </a:p>
         </p:txBody>
@@ -5897,8 +5953,8 @@
         </p:nvSpPr>
         <p:spPr>
           <a:xfrm>
-            <a:off x="731520" y="3657600"/>
-            <a:ext cx="10728655" cy="2194560"/>
+            <a:off x="731520" y="3931920"/>
+            <a:ext cx="10728655" cy="1920240"/>
           </a:xfrm>
           <a:prstGeom prst="rect">
             <a:avLst/>
@@ -6035,13 +6091,13 @@
               </a:spcAft>
             </a:pPr>
             <a:r>
-              <a:rPr sz="2400" b="0" i="0">
+              <a:rPr sz="2100" b="0" i="0">
                 <a:solidFill>
                   <a:srgbClr val="334155"/>
                 </a:solidFill>
                 <a:latin typeface="Arial"/>
               </a:rPr>
-              <a:t>Extensions: PlatformIO IDE, C/C++ -- each with a specific reason, not a long list</a:t>
+              <a:t>Two VS Code extensions do all the real work here: PlatformIO IDE (builds and flashes the firmware, manages the ESP32 toolchain) and C/C++ (syntax highlighting and navigation for the firmware source).</a:t>
             </a:r>
           </a:p>
           <a:p>
@@ -6051,13 +6107,29 @@
               </a:spcAft>
             </a:pPr>
             <a:r>
-              <a:rPr sz="2400" b="0" i="0">
+              <a:rPr sz="2100" b="0" i="0">
                 <a:solidFill>
                   <a:srgbClr val="334155"/>
                 </a:solidFill>
                 <a:latin typeface="Arial"/>
               </a:rPr>
-              <a:t>JetBrains/CLion: the same files, a different terminal</a:t>
+              <a:t>Everything else in this workshop -- Spec Kit's commands, Claude Code, Codex -- works the same way regardless of editor.</a:t>
+            </a:r>
+          </a:p>
+          <a:p>
+            <a:pPr algn="l">
+              <a:spcAft>
+                <a:spcPts val="1200"/>
+              </a:spcAft>
+            </a:pPr>
+            <a:r>
+              <a:rPr sz="2100" b="0" i="0">
+                <a:solidFill>
+                  <a:srgbClr val="334155"/>
+                </a:solidFill>
+                <a:latin typeface="Arial"/>
+              </a:rPr>
+              <a:t>If you use JetBrains/CLion instead: same repository, same files, same Spec Kit commands, just a different terminal and a different set of keyboard shortcuts.</a:t>
             </a:r>
           </a:p>
         </p:txBody>
@@ -6123,8 +6195,8 @@
         </p:nvSpPr>
         <p:spPr>
           <a:xfrm>
-            <a:off x="731520" y="1554480"/>
-            <a:ext cx="10728655" cy="640080"/>
+            <a:off x="731520" y="960120"/>
+            <a:ext cx="10728655" cy="457200"/>
           </a:xfrm>
           <a:prstGeom prst="rect">
             <a:avLst/>
@@ -6132,29 +6204,19 @@
           <a:noFill/>
         </p:spPr>
         <p:txBody>
-          <a:bodyPr wrap="none">
+          <a:bodyPr wrap="square">
             <a:spAutoFit/>
           </a:bodyPr>
           <a:lstStyle/>
           <a:p>
-            <a:pPr algn="l"/>
-            <a:r>
-              <a:rPr b="1" sz="2000">
-                <a:solidFill>
-                  <a:srgbClr val="2563EB"/>
-                </a:solidFill>
-                <a:latin typeface="Courier New"/>
-              </a:rPr>
-              <a:t>Requirements</a:t>
-            </a:r>
-            <a:r>
-              <a:rPr sz="2000">
+            <a:r>
+              <a:rPr sz="1800" i="1">
                 <a:solidFill>
                   <a:srgbClr val="334155"/>
                 </a:solidFill>
                 <a:latin typeface="Arial"/>
               </a:rPr>
-              <a:t>   —   Live in chat history   →   Live as repository files</a:t>
+              <a:t>Same underlying agent, same target hardware -- what changes is where each of these things lives:</a:t>
             </a:r>
           </a:p>
         </p:txBody>
@@ -6167,7 +6229,7 @@
         </p:nvSpPr>
         <p:spPr>
           <a:xfrm>
-            <a:off x="731520" y="2331720"/>
+            <a:off x="731520" y="1554480"/>
             <a:ext cx="10728655" cy="640080"/>
           </a:xfrm>
           <a:prstGeom prst="rect">
@@ -6189,7 +6251,7 @@
                 </a:solidFill>
                 <a:latin typeface="Courier New"/>
               </a:rPr>
-              <a:t>Clarifications</a:t>
+              <a:t>Requirements</a:t>
             </a:r>
             <a:r>
               <a:rPr sz="2000">
@@ -6198,7 +6260,7 @@
                 </a:solidFill>
                 <a:latin typeface="Arial"/>
               </a:rPr>
-              <a:t>   —   Agent assumes on its own   →   Explicit clarification stage</a:t>
+              <a:t>   —   Live in chat history   →   Live as repository files</a:t>
             </a:r>
           </a:p>
         </p:txBody>
@@ -6211,7 +6273,7 @@
         </p:nvSpPr>
         <p:spPr>
           <a:xfrm>
-            <a:off x="731520" y="3108960"/>
+            <a:off x="731520" y="2331720"/>
             <a:ext cx="10728655" cy="640080"/>
           </a:xfrm>
           <a:prstGeom prst="rect">
@@ -6233,6 +6295,50 @@
                 </a:solidFill>
                 <a:latin typeface="Courier New"/>
               </a:rPr>
+              <a:t>Clarifications</a:t>
+            </a:r>
+            <a:r>
+              <a:rPr sz="2000">
+                <a:solidFill>
+                  <a:srgbClr val="334155"/>
+                </a:solidFill>
+                <a:latin typeface="Arial"/>
+              </a:rPr>
+              <a:t>   —   Agent assumes on its own   →   Explicit clarification stage</a:t>
+            </a:r>
+          </a:p>
+        </p:txBody>
+      </p:sp>
+      <p:sp>
+        <p:nvSpPr>
+          <p:cNvPr id="6" name="TextBox 5"/>
+          <p:cNvSpPr txBox="1"/>
+          <p:nvPr/>
+        </p:nvSpPr>
+        <p:spPr>
+          <a:xfrm>
+            <a:off x="731520" y="3108960"/>
+            <a:ext cx="10728655" cy="640080"/>
+          </a:xfrm>
+          <a:prstGeom prst="rect">
+            <a:avLst/>
+          </a:prstGeom>
+          <a:noFill/>
+        </p:spPr>
+        <p:txBody>
+          <a:bodyPr wrap="none">
+            <a:spAutoFit/>
+          </a:bodyPr>
+          <a:lstStyle/>
+          <a:p>
+            <a:pPr algn="l"/>
+            <a:r>
+              <a:rPr b="1" sz="2000">
+                <a:solidFill>
+                  <a:srgbClr val="2563EB"/>
+                </a:solidFill>
+                <a:latin typeface="Courier New"/>
+              </a:rPr>
               <a:t>Traceability</a:t>
             </a:r>
             <a:r>
@@ -6249,7 +6355,7 @@
       </p:sp>
       <p:sp>
         <p:nvSpPr>
-          <p:cNvPr id="6" name="TextBox 5"/>
+          <p:cNvPr id="7" name="TextBox 6"/>
           <p:cNvSpPr txBox="1"/>
           <p:nvPr/>
         </p:nvSpPr>
@@ -6372,13 +6478,13 @@
               </a:spcAft>
             </a:pPr>
             <a:r>
-              <a:rPr sz="2200" b="0" i="0">
+              <a:rPr sz="1900" b="0" i="0">
                 <a:solidFill>
                   <a:srgbClr val="334155"/>
                 </a:solidFill>
                 <a:latin typeface="Arial"/>
               </a:rPr>
-              <a:t>OpenSpec -- similar territory, a different template/command set</a:t>
+              <a:t>Spec Kit is not the only tool in this space -- it's worth knowing it's a design point on a spectrum, not the only option.</a:t>
             </a:r>
           </a:p>
           <a:p>
@@ -6388,13 +6494,13 @@
               </a:spcAft>
             </a:pPr>
             <a:r>
-              <a:rPr sz="2200" b="0" i="0">
-                <a:solidFill>
-                  <a:srgbClr val="334155"/>
-                </a:solidFill>
-                <a:latin typeface="Arial"/>
-              </a:rPr>
-              <a:t>BMAD -- more roles and handoffs, more overhead</a:t>
+              <a:rPr sz="1900" b="1" i="0">
+                <a:solidFill>
+                  <a:srgbClr val="2563EB"/>
+                </a:solidFill>
+                <a:latin typeface="Arial"/>
+              </a:rPr>
+              <a:t>OpenSpec</a:t>
             </a:r>
           </a:p>
           <a:p>
@@ -6404,13 +6510,61 @@
               </a:spcAft>
             </a:pPr>
             <a:r>
-              <a:rPr sz="2200" b="0" i="0">
+              <a:rPr sz="1900" b="0" i="0">
                 <a:solidFill>
                   <a:srgbClr val="334155"/>
                 </a:solidFill>
                 <a:latin typeface="Arial"/>
               </a:rPr>
-              <a:t>Spec Kit sits between free-form prompting and heavy multi-agent processes</a:t>
+              <a:t>covers similar territory -- write specs before code -- with its own template and command conventions.</a:t>
+            </a:r>
+          </a:p>
+          <a:p>
+            <a:pPr algn="l">
+              <a:spcAft>
+                <a:spcPts val="1200"/>
+              </a:spcAft>
+            </a:pPr>
+            <a:r>
+              <a:rPr sz="1900" b="1" i="0">
+                <a:solidFill>
+                  <a:srgbClr val="D97706"/>
+                </a:solidFill>
+                <a:latin typeface="Arial"/>
+              </a:rPr>
+              <a:t>BMAD (Breakthrough Method for Agile AI-Driven Development)</a:t>
+            </a:r>
+          </a:p>
+          <a:p>
+            <a:pPr algn="l">
+              <a:spcAft>
+                <a:spcPts val="1200"/>
+              </a:spcAft>
+            </a:pPr>
+            <a:r>
+              <a:rPr sz="1900" b="0" i="0">
+                <a:solidFill>
+                  <a:srgbClr val="334155"/>
+                </a:solidFill>
+                <a:latin typeface="Arial"/>
+              </a:rPr>
+              <a:t>goes further: multiple defined AI roles (analyst, architect, developer, QA) handing work off to each other, which adds real structure but also real overhead for a small project.</a:t>
+            </a:r>
+          </a:p>
+          <a:p>
+            <a:pPr algn="l">
+              <a:spcAft>
+                <a:spcPts val="1200"/>
+              </a:spcAft>
+            </a:pPr>
+            <a:r>
+              <a:rPr sz="1900" b="1" i="0">
+                <a:solidFill>
+                  <a:srgbClr val="334155"/>
+                </a:solidFill>
+                <a:latin typeface="Arial"/>
+              </a:rPr>
+              <a:t>Spec Kit deliberately sits in the middle: more structure than a bare prompt, far less ceremony than a multi-role framework -- which is why it fits a small embedded-firmware example like this one.</a:t>
             </a:r>
           </a:p>
         </p:txBody>
@@ -6496,13 +6650,13 @@
               </a:spcAft>
             </a:pPr>
             <a:r>
-              <a:rPr sz="2200" b="0" i="0">
+              <a:rPr sz="2000" b="0" i="0">
                 <a:solidFill>
                   <a:srgbClr val="334155"/>
                 </a:solidFill>
                 <a:latin typeface="Arial"/>
               </a:rPr>
-              <a:t>Heltec WiFi Kit V3 (ESP32-S3), built-in OLED, external BME280</a:t>
+              <a:t>The board we're actually building for: a Heltec WiFi Kit V3, which is an ESP32-S3 microcontroller with a built-in small OLED display, plus an external BME280 sensor (temperature/humidity/pressure) wired to it over I2C.</a:t>
             </a:r>
           </a:p>
           <a:p>
@@ -6512,13 +6666,13 @@
               </a:spcAft>
             </a:pPr>
             <a:r>
-              <a:rPr sz="2200" b="1" i="0">
+              <a:rPr sz="2000" b="1" i="0">
                 <a:solidFill>
                   <a:srgbClr val="B91C1C"/>
                 </a:solidFill>
                 <a:latin typeface="Arial"/>
               </a:rPr>
-              <a:t>No built-in environmental sensor on the board -- that's already a product decision</a:t>
+              <a:t>The board has no built-in environmental sensor -- so "which sensor" from slide 3 was never a technical detail, it was a real product decision someone had to make before any code could be correct.</a:t>
             </a:r>
           </a:p>
           <a:p>
@@ -6528,13 +6682,13 @@
               </a:spcAft>
             </a:pPr>
             <a:r>
-              <a:rPr sz="2200" b="0" i="0">
+              <a:rPr sz="2000" b="0" i="0">
                 <a:solidFill>
                   <a:srgbClr val="334155"/>
                 </a:solidFill>
                 <a:latin typeface="Arial"/>
               </a:rPr>
-              <a:t>Surprising technical detail: the display's I2C pins are 17/18, not the ESP32 default (21/22)</a:t>
+              <a:t>One surprising, easy-to-get-wrong technical detail: on this specific board, the built-in display's I2C pins are GPIO 17/18, not the ESP32's usual default I2C pins (21/22) -- get this wrong and the display simply stays blank with no error message.</a:t>
             </a:r>
           </a:p>
         </p:txBody>
@@ -6620,13 +6774,13 @@
               </a:spcAft>
             </a:pPr>
             <a:r>
-              <a:rPr sz="2400" b="1" i="0">
+              <a:rPr sz="2200" b="1" i="0">
                 <a:solidFill>
                   <a:srgbClr val="2563EB"/>
                 </a:solidFill>
                 <a:latin typeface="Arial"/>
               </a:rPr>
-              <a:t>The point: implicit assumption vs. explicit decision</a:t>
+              <a:t>The point of this comparison: implicit assumption vs. explicit decision -- not "bad code vs. good code."</a:t>
             </a:r>
           </a:p>
           <a:p>
@@ -6636,13 +6790,13 @@
               </a:spcAft>
             </a:pPr>
             <a:r>
-              <a:rPr sz="2000" b="0" i="0">
+              <a:rPr sz="1900" b="0" i="0">
                 <a:solidFill>
                   <a:srgbClr val="334155"/>
                 </a:solidFill>
                 <a:latin typeface="Arial"/>
               </a:rPr>
-              <a:t>Hardware wiring (I2C, Vext) is correct in both versions</a:t>
+              <a:t>To keep the comparison fair, the hardware wiring (I2C pins, the Vext power-enable sequence) is correct in both the prompt-only version and the spec-driven version -- wiring mistakes are not the story here.</a:t>
             </a:r>
           </a:p>
           <a:p>
@@ -6652,13 +6806,13 @@
               </a:spcAft>
             </a:pPr>
             <a:r>
-              <a:rPr sz="2000" b="0" i="0">
+              <a:rPr sz="1900" b="0" i="0">
                 <a:solidFill>
                   <a:srgbClr val="334155"/>
                 </a:solidFill>
                 <a:latin typeface="Arial"/>
               </a:rPr>
-              <a:t>What's missing: which sensor, the exact threshold, whether hysteresis is needed</a:t>
+              <a:t>What genuinely differs is everything the original prompt never specified: exactly which sensor to use, the precise numeric threshold, and whether the warning needs any tolerance band (hysteresis) around that threshold.</a:t>
             </a:r>
           </a:p>
           <a:p>
@@ -6668,13 +6822,13 @@
               </a:spcAft>
             </a:pPr>
             <a:r>
-              <a:rPr sz="2000" b="0" i="1">
+              <a:rPr sz="1900" b="0" i="1">
                 <a:solidFill>
                   <a:srgbClr val="334155"/>
                 </a:solidFill>
                 <a:latin typeface="Arial"/>
               </a:rPr>
-              <a:t>Key example: no hysteresis -- not a "bug," the result of a requirement that was never stated</a:t>
+              <a:t>The clearest example: the prompt-only version has no hysteresis at all. That is not a coding bug -- the code does exactly what a reasonable reading of the prompt implies. It's the direct result of a requirement that was simply never stated.</a:t>
             </a:r>
           </a:p>
         </p:txBody>
@@ -6740,8 +6894,8 @@
         </p:nvSpPr>
         <p:spPr>
           <a:xfrm>
-            <a:off x="548640" y="1280160"/>
-            <a:ext cx="11094415" cy="4206240"/>
+            <a:off x="548640" y="1097280"/>
+            <a:ext cx="11094415" cy="1371600"/>
           </a:xfrm>
           <a:prstGeom prst="rect">
             <a:avLst/>
@@ -6760,13 +6914,13 @@
               </a:spcAft>
             </a:pPr>
             <a:r>
-              <a:rPr sz="2200" b="0" i="0">
+              <a:rPr sz="1900" b="0" i="0">
                 <a:solidFill>
                   <a:srgbClr val="334155"/>
                 </a:solidFill>
                 <a:latin typeface="Arial"/>
               </a:rPr>
-              <a:t>The 4 questions actually asked:</a:t>
+              <a:t>specify writes down what the product should do, in plain language, without touching code yet -- essentially a first draft of spec.md.</a:t>
             </a:r>
           </a:p>
           <a:p>
@@ -6776,13 +6930,13 @@
               </a:spcAft>
             </a:pPr>
             <a:r>
-              <a:rPr sz="2200" b="0" i="0">
+              <a:rPr sz="1900" b="0" i="0">
                 <a:solidFill>
                   <a:srgbClr val="334155"/>
                 </a:solidFill>
                 <a:latin typeface="Arial"/>
               </a:rPr>
-              <a:t>Sampling rate • exact threshold bounds • failure debounce • error display content</a:t>
+              <a:t>clarify then asks the human targeted questions about exactly the gaps from slide 3, recording each answer directly into the spec. Below is the real transcript:</a:t>
             </a:r>
           </a:p>
         </p:txBody>
@@ -6803,8 +6957,8 @@
         </p:blipFill>
         <p:spPr>
           <a:xfrm>
-            <a:off x="822960" y="2743200"/>
-            <a:ext cx="10515600" cy="3030967"/>
+            <a:off x="822960" y="2788920"/>
+            <a:ext cx="10058400" cy="2899186"/>
           </a:xfrm>
           <a:prstGeom prst="rect">
             <a:avLst/>
@@ -8349,13 +8503,13 @@
               </a:spcAft>
             </a:pPr>
             <a:r>
-              <a:rPr sz="2200" b="0" i="0">
+              <a:rPr sz="1800" b="0" i="1">
                 <a:solidFill>
                   <a:srgbClr val="334155"/>
                 </a:solidFill>
                 <a:latin typeface="Arial"/>
               </a:rPr>
-              <a:t>Which sensor?</a:t>
+              <a:t>A coding agent still has to answer every one of these -- it just answers them silently, by guessing:</a:t>
             </a:r>
           </a:p>
           <a:p>
@@ -8365,13 +8519,13 @@
               </a:spcAft>
             </a:pPr>
             <a:r>
-              <a:rPr sz="2200" b="0" i="0">
+              <a:rPr sz="1900" b="0" i="0">
                 <a:solidFill>
                   <a:srgbClr val="334155"/>
                 </a:solidFill>
                 <a:latin typeface="Arial"/>
               </a:rPr>
-              <a:t>How often is it sampled?</a:t>
+              <a:t>Which sensor is actually connected? (temperature-only? temperature + humidity? which chip?)</a:t>
             </a:r>
           </a:p>
           <a:p>
@@ -8381,13 +8535,13 @@
               </a:spcAft>
             </a:pPr>
             <a:r>
-              <a:rPr sz="2200" b="0" i="0">
+              <a:rPr sz="1900" b="0" i="0">
                 <a:solidFill>
                   <a:srgbClr val="334155"/>
                 </a:solidFill>
                 <a:latin typeface="Arial"/>
               </a:rPr>
-              <a:t>What exactly is "too high"?</a:t>
+              <a:t>How often should the value be sampled -- once a second, once a minute?</a:t>
             </a:r>
           </a:p>
           <a:p>
@@ -8397,13 +8551,13 @@
               </a:spcAft>
             </a:pPr>
             <a:r>
-              <a:rPr sz="2200" b="0" i="0">
+              <a:rPr sz="1900" b="0" i="0">
                 <a:solidFill>
                   <a:srgbClr val="334155"/>
                 </a:solidFill>
                 <a:latin typeface="Arial"/>
               </a:rPr>
-              <a:t>What happens exactly at the threshold?</a:t>
+              <a:t>What exactly counts as "too high" -- what is the numeric threshold?</a:t>
             </a:r>
           </a:p>
           <a:p>
@@ -8413,13 +8567,13 @@
               </a:spcAft>
             </a:pPr>
             <a:r>
-              <a:rPr sz="2200" b="0" i="0">
+              <a:rPr sz="1900" b="0" i="0">
                 <a:solidFill>
                   <a:srgbClr val="334155"/>
                 </a:solidFill>
                 <a:latin typeface="Arial"/>
               </a:rPr>
-              <a:t>When does the warning clear?</a:t>
+              <a:t>What happens right at the threshold -- does it flicker on and off as the value hovers there?</a:t>
             </a:r>
           </a:p>
           <a:p>
@@ -8429,13 +8583,13 @@
               </a:spcAft>
             </a:pPr>
             <a:r>
-              <a:rPr sz="2200" b="0" i="0">
+              <a:rPr sz="1900" b="0" i="0">
                 <a:solidFill>
                   <a:srgbClr val="334155"/>
                 </a:solidFill>
                 <a:latin typeface="Arial"/>
               </a:rPr>
-              <a:t>What happens if the sensor fails?</a:t>
+              <a:t>Once the warning is showing, at what point does it clear again?</a:t>
             </a:r>
           </a:p>
           <a:p>
@@ -8445,13 +8599,13 @@
               </a:spcAft>
             </a:pPr>
             <a:r>
-              <a:rPr sz="2200" b="0" i="0">
+              <a:rPr sz="1900" b="0" i="0">
                 <a:solidFill>
                   <a:srgbClr val="334155"/>
                 </a:solidFill>
                 <a:latin typeface="Arial"/>
               </a:rPr>
-              <a:t>What does the display show during an error?</a:t>
+              <a:t>What should happen if the sensor stops responding or returns garbage?</a:t>
             </a:r>
           </a:p>
           <a:p>
@@ -8461,13 +8615,29 @@
               </a:spcAft>
             </a:pPr>
             <a:r>
-              <a:rPr sz="2200" b="0" i="0">
+              <a:rPr sz="1900" b="0" i="0">
                 <a:solidFill>
                   <a:srgbClr val="334155"/>
                 </a:solidFill>
                 <a:latin typeface="Arial"/>
               </a:rPr>
-              <a:t>What gets logged to Serial?</a:t>
+              <a:t>What should the display show while that error is happening?</a:t>
+            </a:r>
+          </a:p>
+          <a:p>
+            <a:pPr algn="l">
+              <a:spcAft>
+                <a:spcPts val="1200"/>
+              </a:spcAft>
+            </a:pPr>
+            <a:r>
+              <a:rPr sz="1900" b="0" i="0">
+                <a:solidFill>
+                  <a:srgbClr val="334155"/>
+                </a:solidFill>
+                <a:latin typeface="Arial"/>
+              </a:rPr>
+              <a:t>What, if anything, gets written to the Serial console for debugging?</a:t>
             </a:r>
           </a:p>
         </p:txBody>
@@ -9143,7 +9313,7 @@
                 </a:solidFill>
                 <a:latin typeface="Arial"/>
               </a:rPr>
-              <a:t>What Is GitHub Spec Kit</a:t>
+              <a:t>What Is GitHub Spec Kit -- and Why Does It Exist?</a:t>
             </a:r>
           </a:p>
         </p:txBody>
@@ -9156,8 +9326,8 @@
         </p:nvSpPr>
         <p:spPr>
           <a:xfrm>
-            <a:off x="548640" y="1280160"/>
-            <a:ext cx="11094415" cy="4206240"/>
+            <a:off x="548640" y="1143000"/>
+            <a:ext cx="11094415" cy="4297680"/>
           </a:xfrm>
           <a:prstGeom prst="rect">
             <a:avLst/>
@@ -9176,13 +9346,13 @@
               </a:spcAft>
             </a:pPr>
             <a:r>
-              <a:rPr sz="2400" b="0" i="0">
+              <a:rPr sz="2000" b="1" i="0">
                 <a:solidFill>
                   <a:srgbClr val="334155"/>
                 </a:solidFill>
                 <a:latin typeface="Arial"/>
               </a:rPr>
-              <a:t>Spec Kit = a CLI tool (specify) + a set of Skills/Commands for a coding agent</a:t>
+              <a:t>It's an open-source toolkit published by GitHub (github.com/github/spec-kit) -- free, not a product you buy.</a:t>
             </a:r>
           </a:p>
           <a:p>
@@ -9192,13 +9362,45 @@
               </a:spcAft>
             </a:pPr>
             <a:r>
-              <a:rPr sz="2400" b="0" i="0">
+              <a:rPr sz="2000" b="0" i="0">
                 <a:solidFill>
                   <a:srgbClr val="334155"/>
                 </a:solidFill>
                 <a:latin typeface="Arial"/>
               </a:rPr>
-              <a:t>It doesn't write code itself -- it structures the *process* that leads to writing the code</a:t>
+              <a:t>Concretely, it is two things: a small command-line tool called specify, plus a set of Skills/Commands (the /speckit-... commands we've been showing) that it installs into your AI coding agent -- Claude Code, Codex, or others.</a:t>
+            </a:r>
+          </a:p>
+          <a:p>
+            <a:pPr algn="l">
+              <a:spcAft>
+                <a:spcPts val="1200"/>
+              </a:spcAft>
+            </a:pPr>
+            <a:r>
+              <a:rPr sz="2000" b="0" i="0">
+                <a:solidFill>
+                  <a:srgbClr val="334155"/>
+                </a:solidFill>
+                <a:latin typeface="Arial"/>
+              </a:rPr>
+              <a:t>Spec Kit does not write your application code itself, and it is not an AI model. It structures the *process* a human and an AI agent go through together before and while code gets written: agree on rules, write down requirements, resolve ambiguity, plan the technical approach, break work into tasks, cross-check everything for contradictions, then implement.</a:t>
+            </a:r>
+          </a:p>
+          <a:p>
+            <a:pPr algn="l">
+              <a:spcAft>
+                <a:spcPts val="1200"/>
+              </a:spcAft>
+            </a:pPr>
+            <a:r>
+              <a:rPr sz="1800" b="0" i="0">
+                <a:solidFill>
+                  <a:srgbClr val="334155"/>
+                </a:solidFill>
+                <a:latin typeface="Arial"/>
+              </a:rPr>
+              <a:t>Why GitHub built it: as AI coding agents got fast enough to generate whole features in seconds, teams found the code was rarely the bottleneck anymore -- unclear or unstated requirements were. This pattern is called "spec-driven development," and Spec Kit is GitHub's tooling for it: a practical way to keep the speed of an AI agent without giving up the discipline of knowing what you're actually building.</a:t>
             </a:r>
           </a:p>
         </p:txBody>
@@ -9211,8 +9413,8 @@
         </p:nvSpPr>
         <p:spPr>
           <a:xfrm>
-            <a:off x="731520" y="2926080"/>
-            <a:ext cx="10728655" cy="2560320"/>
+            <a:off x="731520" y="5532120"/>
+            <a:ext cx="10728655" cy="1005840"/>
           </a:xfrm>
           <a:prstGeom prst="rect">
             <a:avLst/>

</xml_diff>